<commit_message>
reorganizes python lessons with schedule
</commit_message>
<xml_diff>
--- a/Intro Slides/Course Intro.pptx
+++ b/Intro Slides/Course Intro.pptx
@@ -210,7 +210,7 @@
           <a:p>
             <a:fld id="{691C588C-9717-44ED-B9A9-CBD9D1909AD4}" type="datetimeFigureOut">
               <a:rPr lang="en-US" smtClean="0"/>
-              <a:t>24-Apr-26</a:t>
+              <a:t>05-May-26</a:t>
             </a:fld>
             <a:endParaRPr lang="en-US"/>
           </a:p>
@@ -633,7 +633,7 @@
           <a:p>
             <a:fld id="{7A3E0868-4E26-4CDC-8A56-D70E2D8B12FE}" type="datetime3">
               <a:rPr lang="en-US" smtClean="0"/>
-              <a:t>24 April 2026</a:t>
+              <a:t>5 May 2026</a:t>
             </a:fld>
             <a:endParaRPr lang="en-US"/>
           </a:p>
@@ -3194,7 +3194,7 @@
           <a:p>
             <a:fld id="{A7B8021B-6105-4216-96FC-94348F216D0E}" type="datetime3">
               <a:rPr lang="en-US" smtClean="0"/>
-              <a:t>24 April 2026</a:t>
+              <a:t>5 May 2026</a:t>
             </a:fld>
             <a:endParaRPr lang="en-US"/>
           </a:p>
@@ -4891,7 +4891,7 @@
           <a:p>
             <a:fld id="{5D27CFAB-73E6-44A8-B862-B3306344E3F2}" type="datetime3">
               <a:rPr lang="en-US" smtClean="0"/>
-              <a:t>24 April 2026</a:t>
+              <a:t>5 May 2026</a:t>
             </a:fld>
             <a:endParaRPr lang="en-US"/>
           </a:p>
@@ -6681,7 +6681,7 @@
           <a:p>
             <a:fld id="{A9B2E784-A5F5-4301-881B-94AC8DBF9DED}" type="datetime3">
               <a:rPr lang="en-US" smtClean="0"/>
-              <a:t>24 April 2026</a:t>
+              <a:t>5 May 2026</a:t>
             </a:fld>
             <a:endParaRPr lang="en-US"/>
           </a:p>
@@ -6860,7 +6860,7 @@
           <a:p>
             <a:fld id="{18EAB3A5-9E92-4BB9-8F22-9632B4FBEDBA}" type="datetime3">
               <a:rPr lang="en-US" smtClean="0"/>
-              <a:t>24 April 2026</a:t>
+              <a:t>5 May 2026</a:t>
             </a:fld>
             <a:endParaRPr lang="en-US"/>
           </a:p>
@@ -7087,7 +7087,7 @@
           <a:p>
             <a:fld id="{40923810-5FB2-48C9-96CA-1DE2C4773142}" type="datetime3">
               <a:rPr lang="en-US" smtClean="0"/>
-              <a:t>24 April 2026</a:t>
+              <a:t>5 May 2026</a:t>
             </a:fld>
             <a:endParaRPr lang="en-US"/>
           </a:p>
@@ -7377,7 +7377,7 @@
           <a:p>
             <a:fld id="{E50EFF4B-86EB-42FB-93EA-7D8F9CB2466F}" type="datetime3">
               <a:rPr lang="en-US" smtClean="0"/>
-              <a:t>24 April 2026</a:t>
+              <a:t>5 May 2026</a:t>
             </a:fld>
             <a:endParaRPr lang="en-US"/>
           </a:p>
@@ -7989,7 +7989,7 @@
           <a:p>
             <a:fld id="{FB14FC24-E041-45E9-9A72-E5755A86890F}" type="datetime3">
               <a:rPr lang="en-US" smtClean="0"/>
-              <a:t>24 April 2026</a:t>
+              <a:t>5 May 2026</a:t>
             </a:fld>
             <a:endParaRPr lang="en-US"/>
           </a:p>
@@ -8849,7 +8849,7 @@
           <a:p>
             <a:fld id="{98A19125-94A7-4474-858C-FD9C4ABE9DDA}" type="datetime3">
               <a:rPr lang="en-US" smtClean="0"/>
-              <a:t>24 April 2026</a:t>
+              <a:t>5 May 2026</a:t>
             </a:fld>
             <a:endParaRPr lang="en-US"/>
           </a:p>
@@ -9952,7 +9952,7 @@
           <a:p>
             <a:fld id="{3BA0343D-C8D8-43CE-BB79-50DEA219DB07}" type="datetime3">
               <a:rPr lang="en-US" smtClean="0"/>
-              <a:t>24 April 2026</a:t>
+              <a:t>5 May 2026</a:t>
             </a:fld>
             <a:endParaRPr lang="en-US"/>
           </a:p>
@@ -10241,7 +10241,7 @@
           <a:p>
             <a:fld id="{453BD212-0B9F-4987-965F-AC83B2FC354F}" type="datetime3">
               <a:rPr lang="en-US" smtClean="0"/>
-              <a:t>24 April 2026</a:t>
+              <a:t>5 May 2026</a:t>
             </a:fld>
             <a:endParaRPr lang="en-US"/>
           </a:p>
@@ -10484,7 +10484,7 @@
           <a:p>
             <a:fld id="{6DDC931E-8CBE-4A3F-A034-9B6122C6DCDB}" type="datetime3">
               <a:rPr lang="en-US" smtClean="0"/>
-              <a:t>24 April 2026</a:t>
+              <a:t>5 May 2026</a:t>
             </a:fld>
             <a:endParaRPr lang="en-US"/>
           </a:p>
@@ -12250,7 +12250,7 @@
           <a:p>
             <a:fld id="{220AF9C2-5E8A-4308-AE6B-CA9B65007D0E}" type="datetime3">
               <a:rPr lang="en-US" smtClean="0"/>
-              <a:t>24 April 2026</a:t>
+              <a:t>5 May 2026</a:t>
             </a:fld>
             <a:endParaRPr lang="en-US"/>
           </a:p>
@@ -12563,7 +12563,7 @@
           <a:p>
             <a:fld id="{FF31E861-D2AF-431D-860B-DCF67C218052}" type="datetime3">
               <a:rPr lang="en-US" smtClean="0"/>
-              <a:t>24 April 2026</a:t>
+              <a:t>5 May 2026</a:t>
             </a:fld>
             <a:endParaRPr lang="en-US"/>
           </a:p>
@@ -12842,7 +12842,7 @@
           <a:p>
             <a:fld id="{D1DA25B2-AAF1-4C1F-AA38-12D5BFA7D4C8}" type="datetime3">
               <a:rPr lang="en-US" smtClean="0"/>
-              <a:t>24 April 2026</a:t>
+              <a:t>5 May 2026</a:t>
             </a:fld>
             <a:endParaRPr lang="en-US"/>
           </a:p>
@@ -13121,7 +13121,7 @@
           <a:p>
             <a:fld id="{A25C0F39-45D0-48E9-90B3-7FE8FCE561C8}" type="datetime3">
               <a:rPr lang="en-US" smtClean="0"/>
-              <a:t>24 April 2026</a:t>
+              <a:t>5 May 2026</a:t>
             </a:fld>
             <a:endParaRPr lang="en-US"/>
           </a:p>
@@ -13622,7 +13622,7 @@
           <a:p>
             <a:fld id="{9BAF1A3D-92FA-4F24-9781-74AFA516A230}" type="datetime3">
               <a:rPr lang="en-US" smtClean="0"/>
-              <a:t>24 April 2026</a:t>
+              <a:t>5 May 2026</a:t>
             </a:fld>
             <a:endParaRPr lang="en-US"/>
           </a:p>
@@ -13749,7 +13749,7 @@
           <a:p>
             <a:fld id="{5719C672-856D-4617-A693-8FE15749A9B7}" type="datetime3">
               <a:rPr lang="en-US" smtClean="0"/>
-              <a:t>24 April 2026</a:t>
+              <a:t>5 May 2026</a:t>
             </a:fld>
             <a:endParaRPr lang="en-US"/>
           </a:p>
@@ -13884,7 +13884,7 @@
           <a:p>
             <a:fld id="{5F6C764D-A39E-4C03-B161-E0BC66E8883B}" type="datetime3">
               <a:rPr lang="en-US" smtClean="0"/>
-              <a:t>24 April 2026</a:t>
+              <a:t>5 May 2026</a:t>
             </a:fld>
             <a:endParaRPr lang="en-US"/>
           </a:p>
@@ -14122,7 +14122,7 @@
           <a:p>
             <a:fld id="{6E3E33F9-20B7-4995-BE7D-165DBB597850}" type="datetime3">
               <a:rPr lang="en-US" smtClean="0"/>
-              <a:t>24 April 2026</a:t>
+              <a:t>5 May 2026</a:t>
             </a:fld>
             <a:endParaRPr lang="en-US"/>
           </a:p>
@@ -14235,7 +14235,7 @@
           <a:p>
             <a:fld id="{CD41C263-3501-4369-A962-62B6BF915CDE}" type="datetime3">
               <a:rPr lang="en-US" smtClean="0"/>
-              <a:t>24 April 2026</a:t>
+              <a:t>5 May 2026</a:t>
             </a:fld>
             <a:endParaRPr lang="en-US"/>
           </a:p>
@@ -14638,7 +14638,7 @@
           <a:p>
             <a:fld id="{B06F3EBE-B2E8-4992-9F00-9E4B44F057C0}" type="datetime3">
               <a:rPr lang="en-US" smtClean="0"/>
-              <a:t>24 April 2026</a:t>
+              <a:t>5 May 2026</a:t>
             </a:fld>
             <a:endParaRPr lang="en-US"/>
           </a:p>
@@ -14770,7 +14770,7 @@
           <a:p>
             <a:fld id="{D41656AB-D2E1-472E-8B95-0DF5C6E1D623}" type="datetime3">
               <a:rPr lang="en-US" smtClean="0"/>
-              <a:t>24 April 2026</a:t>
+              <a:t>5 May 2026</a:t>
             </a:fld>
             <a:endParaRPr lang="en-US"/>
           </a:p>
@@ -16631,7 +16631,7 @@
           <a:p>
             <a:fld id="{AD622D1A-DF83-41A8-85FF-04D90BF831D3}" type="datetime3">
               <a:rPr lang="en-US" smtClean="0"/>
-              <a:t>24 April 2026</a:t>
+              <a:t>5 May 2026</a:t>
             </a:fld>
             <a:endParaRPr lang="en-US"/>
           </a:p>
@@ -16881,7 +16881,7 @@
           <a:p>
             <a:fld id="{334F72C3-CDF3-44A8-B602-1649B1728485}" type="datetime3">
               <a:rPr lang="en-US" smtClean="0"/>
-              <a:t>24 April 2026</a:t>
+              <a:t>5 May 2026</a:t>
             </a:fld>
             <a:endParaRPr lang="en-US"/>
           </a:p>
@@ -17188,7 +17188,7 @@
           <a:p>
             <a:fld id="{1E0132BA-B5E7-4FFD-AF6C-169169D47D4A}" type="datetime3">
               <a:rPr lang="en-US" smtClean="0"/>
-              <a:t>24 April 2026</a:t>
+              <a:t>5 May 2026</a:t>
             </a:fld>
             <a:endParaRPr lang="en-US"/>
           </a:p>
@@ -17669,7 +17669,7 @@
           <a:p>
             <a:fld id="{81A30091-1C2A-4151-8D3C-D1E47A72615F}" type="datetime3">
               <a:rPr lang="en-US" smtClean="0"/>
-              <a:t>24 April 2026</a:t>
+              <a:t>5 May 2026</a:t>
             </a:fld>
             <a:endParaRPr lang="en-US"/>
           </a:p>
@@ -18306,7 +18306,7 @@
           <a:p>
             <a:fld id="{35D703CE-07B4-4C05-A488-B4566700621F}" type="datetime3">
               <a:rPr lang="en-US" smtClean="0"/>
-              <a:t>24 April 2026</a:t>
+              <a:t>5 May 2026</a:t>
             </a:fld>
             <a:endParaRPr lang="en-US"/>
           </a:p>
@@ -19364,7 +19364,7 @@
           <a:p>
             <a:fld id="{694BD61C-20BA-43AF-A21F-1DAFB3200099}" type="datetime3">
               <a:rPr lang="en-US" smtClean="0"/>
-              <a:t>24 April 2026</a:t>
+              <a:t>5 May 2026</a:t>
             </a:fld>
             <a:endParaRPr lang="en-US"/>
           </a:p>
@@ -19851,7 +19851,7 @@
           <a:p>
             <a:fld id="{CABCB1B0-B6E5-4DD1-BB55-95C076D6C0C8}" type="datetime3">
               <a:rPr lang="en-US" smtClean="0"/>
-              <a:t>24 April 2026</a:t>
+              <a:t>5 May 2026</a:t>
             </a:fld>
             <a:endParaRPr lang="en-US"/>
           </a:p>
@@ -20393,7 +20393,7 @@
           <a:p>
             <a:fld id="{7A3E0868-4E26-4CDC-8A56-D70E2D8B12FE}" type="datetime3">
               <a:rPr lang="en-US" smtClean="0"/>
-              <a:t>24 April 2026</a:t>
+              <a:t>5 May 2026</a:t>
             </a:fld>
             <a:endParaRPr lang="en-US"/>
           </a:p>
@@ -20958,7 +20958,7 @@
           <a:p>
             <a:fld id="{334F72C3-CDF3-44A8-B602-1649B1728485}" type="datetime3">
               <a:rPr lang="en-US" smtClean="0"/>
-              <a:t>24 April 2026</a:t>
+              <a:t>5 May 2026</a:t>
             </a:fld>
             <a:endParaRPr lang="en-US"/>
           </a:p>
@@ -21187,7 +21187,7 @@
           <a:p>
             <a:fld id="{334F72C3-CDF3-44A8-B602-1649B1728485}" type="datetime3">
               <a:rPr lang="en-US" smtClean="0"/>
-              <a:t>24 April 2026</a:t>
+              <a:t>5 May 2026</a:t>
             </a:fld>
             <a:endParaRPr lang="en-US"/>
           </a:p>
@@ -21336,7 +21336,7 @@
           <a:p>
             <a:fld id="{334F72C3-CDF3-44A8-B602-1649B1728485}" type="datetime3">
               <a:rPr lang="en-US" smtClean="0"/>
-              <a:t>24 April 2026</a:t>
+              <a:t>5 May 2026</a:t>
             </a:fld>
             <a:endParaRPr lang="en-US"/>
           </a:p>
@@ -21671,7 +21671,7 @@
           <a:p>
             <a:fld id="{334F72C3-CDF3-44A8-B602-1649B1728485}" type="datetime3">
               <a:rPr lang="en-US" smtClean="0"/>
-              <a:t>24 April 2026</a:t>
+              <a:t>5 May 2026</a:t>
             </a:fld>
             <a:endParaRPr lang="en-US"/>
           </a:p>
@@ -21827,7 +21827,7 @@
           <a:p>
             <a:fld id="{AD622D1A-DF83-41A8-85FF-04D90BF831D3}" type="datetime3">
               <a:rPr lang="en-US" smtClean="0"/>
-              <a:t>24 April 2026</a:t>
+              <a:t>5 May 2026</a:t>
             </a:fld>
             <a:endParaRPr lang="en-US"/>
           </a:p>
@@ -21981,7 +21981,7 @@
           <a:p>
             <a:fld id="{AD622D1A-DF83-41A8-85FF-04D90BF831D3}" type="datetime3">
               <a:rPr lang="en-US" smtClean="0"/>
-              <a:t>24 April 2026</a:t>
+              <a:t>5 May 2026</a:t>
             </a:fld>
             <a:endParaRPr lang="en-US"/>
           </a:p>
@@ -22098,19 +22098,19 @@
           <a:p>
             <a:r>
               <a:rPr lang="en-US" dirty="0"/>
-              <a:t>Summer prep</a:t>
+              <a:t>Summer prep (Jul – Aug)</a:t>
             </a:r>
           </a:p>
           <a:p>
             <a:r>
               <a:rPr lang="en-US" dirty="0"/>
-              <a:t>CMU course</a:t>
+              <a:t>CMU course (Aug – May)</a:t>
             </a:r>
           </a:p>
           <a:p>
             <a:r>
               <a:rPr lang="en-US" dirty="0"/>
-              <a:t>AI2C specifics</a:t>
+              <a:t>Factory specifics (May – Jun, TBD)</a:t>
             </a:r>
           </a:p>
         </p:txBody>
@@ -22138,7 +22138,7 @@
           <a:p>
             <a:fld id="{6DDC931E-8CBE-4A3F-A034-9B6122C6DCDB}" type="datetime3">
               <a:rPr lang="en-US" smtClean="0"/>
-              <a:t>24 April 2026</a:t>
+              <a:t>5 May 2026</a:t>
             </a:fld>
             <a:endParaRPr lang="en-US"/>
           </a:p>
@@ -22287,7 +22287,7 @@
           <a:p>
             <a:fld id="{334F72C3-CDF3-44A8-B602-1649B1728485}" type="datetime3">
               <a:rPr lang="en-US" smtClean="0"/>
-              <a:t>24 April 2026</a:t>
+              <a:t>5 May 2026</a:t>
             </a:fld>
             <a:endParaRPr lang="en-US"/>
           </a:p>
@@ -22454,7 +22454,7 @@
           <a:p>
             <a:fld id="{334F72C3-CDF3-44A8-B602-1649B1728485}" type="datetime3">
               <a:rPr lang="en-US" smtClean="0"/>
-              <a:t>24 April 2026</a:t>
+              <a:t>5 May 2026</a:t>
             </a:fld>
             <a:endParaRPr lang="en-US"/>
           </a:p>
@@ -22621,7 +22621,7 @@
           <a:p>
             <a:fld id="{334F72C3-CDF3-44A8-B602-1649B1728485}" type="datetime3">
               <a:rPr lang="en-US" smtClean="0"/>
-              <a:t>24 April 2026</a:t>
+              <a:t>5 May 2026</a:t>
             </a:fld>
             <a:endParaRPr lang="en-US"/>
           </a:p>
@@ -22709,8 +22709,12 @@
           <a:lstStyle/>
           <a:p>
             <a:r>
+              <a:rPr lang="en-US"/>
+              <a:t>Factory </a:t>
+            </a:r>
+            <a:r>
               <a:rPr lang="en-US" dirty="0"/>
-              <a:t>AI2C Specifics - TBD</a:t>
+              <a:t>Specifics - TBD</a:t>
             </a:r>
           </a:p>
         </p:txBody>
@@ -22770,7 +22774,7 @@
           <a:p>
             <a:fld id="{334F72C3-CDF3-44A8-B602-1649B1728485}" type="datetime3">
               <a:rPr lang="en-US" smtClean="0"/>
-              <a:t>24 April 2026</a:t>
+              <a:t>5 May 2026</a:t>
             </a:fld>
             <a:endParaRPr lang="en-US"/>
           </a:p>
@@ -22949,7 +22953,7 @@
           <a:p>
             <a:fld id="{AD622D1A-DF83-41A8-85FF-04D90BF831D3}" type="datetime3">
               <a:rPr lang="en-US" smtClean="0"/>
-              <a:t>24 April 2026</a:t>
+              <a:t>5 May 2026</a:t>
             </a:fld>
             <a:endParaRPr lang="en-US"/>
           </a:p>
@@ -23116,7 +23120,7 @@
           <a:p>
             <a:fld id="{334F72C3-CDF3-44A8-B602-1649B1728485}" type="datetime3">
               <a:rPr lang="en-US" smtClean="0"/>
-              <a:t>24 April 2026</a:t>
+              <a:t>5 May 2026</a:t>
             </a:fld>
             <a:endParaRPr lang="en-US"/>
           </a:p>
@@ -23721,6 +23725,187 @@
 </file>
 
 <file path=customXml/item1.xml><?xml version="1.0" encoding="utf-8"?>
+<p:properties xmlns:p="http://schemas.microsoft.com/office/2006/metadata/properties" xmlns:xsi="http://www.w3.org/2001/XMLSchema-instance" xmlns:pc="http://schemas.microsoft.com/office/infopath/2007/PartnerControls">
+  <documentManagement>
+    <Name_x0028_Outlook_x0029_ xmlns="819a213c-e595-4af7-868c-5311d0f07b09">
+      <UserInfo>
+        <DisplayName/>
+        <AccountId xsi:nil="true"/>
+        <AccountType/>
+      </UserInfo>
+    </Name_x0028_Outlook_x0029_>
+    <_ip_UnifiedCompliancePolicyUIAction xmlns="http://schemas.microsoft.com/sharepoint/v3" xsi:nil="true"/>
+    <TaxCatchAll xmlns="43c4306d-bcae-48a3-b5b4-6245fba36c72">
+      <Value>117</Value>
+      <Value>336</Value>
+      <Value>352</Value>
+      <Value>332</Value>
+      <Value>330</Value>
+      <Value>5</Value>
+      <Value>88</Value>
+      <Value>2</Value>
+      <Value>1</Value>
+    </TaxCatchAll>
+    <Project xmlns="819a213c-e595-4af7-868c-5311d0f07b09">Shrike</Project>
+    <b3e0283348f04d719dc2db6c1ad0eab0 xmlns="819a213c-e595-4af7-868c-5311d0f07b09">
+      <Terms xmlns="http://schemas.microsoft.com/office/infopath/2007/PartnerControls"/>
+    </b3e0283348f04d719dc2db6c1ad0eab0>
+    <kf4578e6b9744d06891b013fb9171991 xmlns="819a213c-e595-4af7-868c-5311d0f07b09">
+      <Terms xmlns="http://schemas.microsoft.com/office/infopath/2007/PartnerControls">
+        <TermInfo xmlns="http://schemas.microsoft.com/office/infopath/2007/PartnerControls">
+          <TermName xmlns="http://schemas.microsoft.com/office/infopath/2007/PartnerControls">FCAI</TermName>
+          <TermId xmlns="http://schemas.microsoft.com/office/infopath/2007/PartnerControls">fd9e9f27-4afa-4bd6-9815-b72522a6dee4</TermId>
+        </TermInfo>
+      </Terms>
+    </kf4578e6b9744d06891b013fb9171991>
+    <e7bf107ab2e246c2ae3b25ccb19c4fe7 xmlns="819a213c-e595-4af7-868c-5311d0f07b09">
+      <Terms xmlns="http://schemas.microsoft.com/office/infopath/2007/PartnerControls"/>
+    </e7bf107ab2e246c2ae3b25ccb19c4fe7>
+    <Status xmlns="819a213c-e595-4af7-868c-5311d0f07b09">NA</Status>
+    <k1cd0d7a50e348e5b2cecacdbb53a3ff xmlns="819a213c-e595-4af7-868c-5311d0f07b09">
+      <Terms xmlns="http://schemas.microsoft.com/office/infopath/2007/PartnerControls">
+        <TermInfo xmlns="http://schemas.microsoft.com/office/infopath/2007/PartnerControls">
+          <TermName xmlns="http://schemas.microsoft.com/office/infopath/2007/PartnerControls">NA</TermName>
+          <TermId xmlns="http://schemas.microsoft.com/office/infopath/2007/PartnerControls">6c779868-fdfe-4433-a583-74f72965e832</TermId>
+        </TermInfo>
+      </Terms>
+    </k1cd0d7a50e348e5b2cecacdbb53a3ff>
+    <k4bd3d618c344bb496a0035fa1bfa95e xmlns="819a213c-e595-4af7-868c-5311d0f07b09">
+      <Terms xmlns="http://schemas.microsoft.com/office/infopath/2007/PartnerControls">
+        <TermInfo xmlns="http://schemas.microsoft.com/office/infopath/2007/PartnerControls">
+          <TermName xmlns="http://schemas.microsoft.com/office/infopath/2007/PartnerControls">NA</TermName>
+          <TermId xmlns="http://schemas.microsoft.com/office/infopath/2007/PartnerControls">14e9068e-14f9-49cc-a753-38a742264b27</TermId>
+        </TermInfo>
+      </Terms>
+    </k4bd3d618c344bb496a0035fa1bfa95e>
+    <m3911d227d12438196938f21bccbb829 xmlns="819a213c-e595-4af7-868c-5311d0f07b09">
+      <Terms xmlns="http://schemas.microsoft.com/office/infopath/2007/PartnerControls">
+        <TermInfo xmlns="http://schemas.microsoft.com/office/infopath/2007/PartnerControls">
+          <TermName xmlns="http://schemas.microsoft.com/office/infopath/2007/PartnerControls">Unclassified</TermName>
+          <TermId xmlns="http://schemas.microsoft.com/office/infopath/2007/PartnerControls">0e44ab2e-9e75-4d69-bacf-b9adbba64961</TermId>
+        </TermInfo>
+      </Terms>
+    </m3911d227d12438196938f21bccbb829>
+    <j85403ed819e4ad59bb8aa44734c7278 xmlns="819a213c-e595-4af7-868c-5311d0f07b09">
+      <Terms xmlns="http://schemas.microsoft.com/office/infopath/2007/PartnerControls">
+        <TermInfo xmlns="http://schemas.microsoft.com/office/infopath/2007/PartnerControls">
+          <TermName xmlns="http://schemas.microsoft.com/office/infopath/2007/PartnerControls">NA</TermName>
+          <TermId xmlns="http://schemas.microsoft.com/office/infopath/2007/PartnerControls">c413e2e5-7da6-4fb4-9318-c07a4c95104c</TermId>
+        </TermInfo>
+      </Terms>
+    </j85403ed819e4ad59bb8aa44734c7278>
+    <e41571422c3345b4bda9d3ac979b0442 xmlns="819a213c-e595-4af7-868c-5311d0f07b09">
+      <Terms xmlns="http://schemas.microsoft.com/office/infopath/2007/PartnerControls">
+        <TermInfo xmlns="http://schemas.microsoft.com/office/infopath/2007/PartnerControls">
+          <TermName xmlns="http://schemas.microsoft.com/office/infopath/2007/PartnerControls">Destroy</TermName>
+          <TermId xmlns="http://schemas.microsoft.com/office/infopath/2007/PartnerControls">81460359-14dd-47b4-9102-5fada66d1614</TermId>
+        </TermInfo>
+      </Terms>
+    </e41571422c3345b4bda9d3ac979b0442>
+    <b2c7cbb6fa064dd095a8ebf73878e15c xmlns="819a213c-e595-4af7-868c-5311d0f07b09">
+      <Terms xmlns="http://schemas.microsoft.com/office/infopath/2007/PartnerControls">
+        <TermInfo xmlns="http://schemas.microsoft.com/office/infopath/2007/PartnerControls">
+          <TermName xmlns="http://schemas.microsoft.com/office/infopath/2007/PartnerControls">D</TermName>
+          <TermId xmlns="http://schemas.microsoft.com/office/infopath/2007/PartnerControls">e66b2925-d207-445d-a7ac-7bf5587a61c3</TermId>
+        </TermInfo>
+      </Terms>
+    </b2c7cbb6fa064dd095a8ebf73878e15c>
+    <n050dff107b041e7a8136cabb03c9f16 xmlns="819a213c-e595-4af7-868c-5311d0f07b09">
+      <Terms xmlns="http://schemas.microsoft.com/office/infopath/2007/PartnerControls"/>
+    </n050dff107b041e7a8136cabb03c9f16>
+    <dbcc5996da9743a2aff52ccb96daf316 xmlns="819a213c-e595-4af7-868c-5311d0f07b09">
+      <Terms xmlns="http://schemas.microsoft.com/office/infopath/2007/PartnerControls"/>
+    </dbcc5996da9743a2aff52ccb96daf316>
+    <_ip_UnifiedCompliancePolicyProperties xmlns="http://schemas.microsoft.com/sharepoint/v3" xsi:nil="true"/>
+    <Comments xmlns="819a213c-e595-4af7-868c-5311d0f07b09" xsi:nil="true"/>
+    <_dlc_DocIdPersistId xmlns="43c4306d-bcae-48a3-b5b4-6245fba36c72" xsi:nil="true"/>
+    <_dlc_DocIdUrl xmlns="43c4306d-bcae-48a3-b5b4-6245fba36c72">
+      <Url>https://armyeitaas.sharepoint-mil.us/teams/AI2CKMDevelopmentTeam/_layouts/15/DocIdRedir.aspx?ID=PNCAVZZWCJMJ-719779062-26496</Url>
+      <Description>PNCAVZZWCJMJ-719779062-26496</Description>
+    </_dlc_DocIdUrl>
+    <Teams xmlns="819a213c-e595-4af7-868c-5311d0f07b09">NA</Teams>
+    <lcf76f155ced4ddcb4097134ff3c332f xmlns="819a213c-e595-4af7-868c-5311d0f07b09">
+      <Terms xmlns="http://schemas.microsoft.com/office/infopath/2007/PartnerControls"/>
+    </lcf76f155ced4ddcb4097134ff3c332f>
+    <kf187aa08ef840c0be306c2b7cf181cc xmlns="819a213c-e595-4af7-868c-5311d0f07b09">
+      <Terms xmlns="http://schemas.microsoft.com/office/infopath/2007/PartnerControls"/>
+    </kf187aa08ef840c0be306c2b7cf181cc>
+    <k8ed72fc0ac74230bc2bce9a30aa3ff1 xmlns="819a213c-e595-4af7-868c-5311d0f07b09">
+      <Terms xmlns="http://schemas.microsoft.com/office/infopath/2007/PartnerControls"/>
+    </k8ed72fc0ac74230bc2bce9a30aa3ff1>
+    <j3cec2dc15da4ea9ae4c2914aab734b8 xmlns="819a213c-e595-4af7-868c-5311d0f07b09">
+      <Terms xmlns="http://schemas.microsoft.com/office/infopath/2007/PartnerControls">
+        <TermInfo xmlns="http://schemas.microsoft.com/office/infopath/2007/PartnerControls">
+          <TermName xmlns="http://schemas.microsoft.com/office/infopath/2007/PartnerControls">Unofficial</TermName>
+          <TermId xmlns="http://schemas.microsoft.com/office/infopath/2007/PartnerControls">fb72a3e1-cd07-4e90-8aa1-1e35bcf7448f</TermId>
+        </TermInfo>
+      </Terms>
+    </j3cec2dc15da4ea9ae4c2914aab734b8>
+    <_dlc_DocId xmlns="43c4306d-bcae-48a3-b5b4-6245fba36c72">PNCAVZZWCJMJ-719779062-26496</_dlc_DocId>
+  </documentManagement>
+</p:properties>
+</file>
+
+<file path=customXml/item2.xml><?xml version="1.0" encoding="utf-8"?>
+<?mso-contentType ?>
+<FormTemplates xmlns="http://schemas.microsoft.com/sharepoint/v3/contenttype/forms">
+  <Display>DocumentLibraryForm</Display>
+  <Edit>DocumentLibraryForm</Edit>
+  <New>DocumentLibraryForm</New>
+</FormTemplates>
+</file>
+
+<file path=customXml/item3.xml><?xml version="1.0" encoding="utf-8"?>
+<?mso-contentType ?>
+<spe:Receivers xmlns:spe="http://schemas.microsoft.com/sharepoint/events">
+  <Receiver>
+    <Name>Document ID Generator</Name>
+    <Synchronization>Synchronous</Synchronization>
+    <Type>10001</Type>
+    <SequenceNumber>1000</SequenceNumber>
+    <Url/>
+    <Assembly>Microsoft.Office.DocumentManagement, Version=16.0.0.0, Culture=neutral, PublicKeyToken=71e9bce111e9429c</Assembly>
+    <Class>Microsoft.Office.DocumentManagement.Internal.DocIdHandler</Class>
+    <Data/>
+    <Filter/>
+  </Receiver>
+  <Receiver>
+    <Name>Document ID Generator</Name>
+    <Synchronization>Synchronous</Synchronization>
+    <Type>10002</Type>
+    <SequenceNumber>1001</SequenceNumber>
+    <Url/>
+    <Assembly>Microsoft.Office.DocumentManagement, Version=16.0.0.0, Culture=neutral, PublicKeyToken=71e9bce111e9429c</Assembly>
+    <Class>Microsoft.Office.DocumentManagement.Internal.DocIdHandler</Class>
+    <Data/>
+    <Filter/>
+  </Receiver>
+  <Receiver>
+    <Name>Document ID Generator</Name>
+    <Synchronization>Synchronous</Synchronization>
+    <Type>10004</Type>
+    <SequenceNumber>1002</SequenceNumber>
+    <Url/>
+    <Assembly>Microsoft.Office.DocumentManagement, Version=16.0.0.0, Culture=neutral, PublicKeyToken=71e9bce111e9429c</Assembly>
+    <Class>Microsoft.Office.DocumentManagement.Internal.DocIdHandler</Class>
+    <Data/>
+    <Filter/>
+  </Receiver>
+  <Receiver>
+    <Name>Document ID Generator</Name>
+    <Synchronization>Synchronous</Synchronization>
+    <Type>10006</Type>
+    <SequenceNumber>1003</SequenceNumber>
+    <Url/>
+    <Assembly>Microsoft.Office.DocumentManagement, Version=16.0.0.0, Culture=neutral, PublicKeyToken=71e9bce111e9429c</Assembly>
+    <Class>Microsoft.Office.DocumentManagement.Internal.DocIdHandler</Class>
+    <Data/>
+    <Filter/>
+  </Receiver>
+</spe:Receivers>
+</file>
+
+<file path=customXml/item4.xml><?xml version="1.0" encoding="utf-8"?>
 <ct:contentTypeSchema xmlns:ct="http://schemas.microsoft.com/office/2006/metadata/contentType" xmlns:ma="http://schemas.microsoft.com/office/2006/metadata/properties/metaAttributes" ct:_="" ma:_="" ma:contentTypeName="Document" ma:contentTypeID="0x010100744FEF590B341F46AAAF568C3B82DA74" ma:contentTypeVersion="126" ma:contentTypeDescription="Create a new document." ma:contentTypeScope="" ma:versionID="da2759216466bc3ec804369b15a902a5">
   <xsd:schema xmlns:xsd="http://www.w3.org/2001/XMLSchema" xmlns:xs="http://www.w3.org/2001/XMLSchema" xmlns:p="http://schemas.microsoft.com/office/2006/metadata/properties" xmlns:ns1="http://schemas.microsoft.com/sharepoint/v3" xmlns:ns2="819a213c-e595-4af7-868c-5311d0f07b09" xmlns:ns3="43c4306d-bcae-48a3-b5b4-6245fba36c72" targetNamespace="http://schemas.microsoft.com/office/2006/metadata/properties" ma:root="true" ma:fieldsID="23a203c7101a14e7e286c2f61aba86b7" ns1:_="" ns2:_="" ns3:_="">
     <xsd:import namespace="http://schemas.microsoft.com/sharepoint/v3"/>
@@ -24179,188 +24364,35 @@
 </ct:contentTypeSchema>
 </file>
 
-<file path=customXml/item2.xml><?xml version="1.0" encoding="utf-8"?>
-<?mso-contentType ?>
-<spe:Receivers xmlns:spe="http://schemas.microsoft.com/sharepoint/events">
-  <Receiver>
-    <Name>Document ID Generator</Name>
-    <Synchronization>Synchronous</Synchronization>
-    <Type>10001</Type>
-    <SequenceNumber>1000</SequenceNumber>
-    <Url/>
-    <Assembly>Microsoft.Office.DocumentManagement, Version=16.0.0.0, Culture=neutral, PublicKeyToken=71e9bce111e9429c</Assembly>
-    <Class>Microsoft.Office.DocumentManagement.Internal.DocIdHandler</Class>
-    <Data/>
-    <Filter/>
-  </Receiver>
-  <Receiver>
-    <Name>Document ID Generator</Name>
-    <Synchronization>Synchronous</Synchronization>
-    <Type>10002</Type>
-    <SequenceNumber>1001</SequenceNumber>
-    <Url/>
-    <Assembly>Microsoft.Office.DocumentManagement, Version=16.0.0.0, Culture=neutral, PublicKeyToken=71e9bce111e9429c</Assembly>
-    <Class>Microsoft.Office.DocumentManagement.Internal.DocIdHandler</Class>
-    <Data/>
-    <Filter/>
-  </Receiver>
-  <Receiver>
-    <Name>Document ID Generator</Name>
-    <Synchronization>Synchronous</Synchronization>
-    <Type>10004</Type>
-    <SequenceNumber>1002</SequenceNumber>
-    <Url/>
-    <Assembly>Microsoft.Office.DocumentManagement, Version=16.0.0.0, Culture=neutral, PublicKeyToken=71e9bce111e9429c</Assembly>
-    <Class>Microsoft.Office.DocumentManagement.Internal.DocIdHandler</Class>
-    <Data/>
-    <Filter/>
-  </Receiver>
-  <Receiver>
-    <Name>Document ID Generator</Name>
-    <Synchronization>Synchronous</Synchronization>
-    <Type>10006</Type>
-    <SequenceNumber>1003</SequenceNumber>
-    <Url/>
-    <Assembly>Microsoft.Office.DocumentManagement, Version=16.0.0.0, Culture=neutral, PublicKeyToken=71e9bce111e9429c</Assembly>
-    <Class>Microsoft.Office.DocumentManagement.Internal.DocIdHandler</Class>
-    <Data/>
-    <Filter/>
-  </Receiver>
-</spe:Receivers>
+<file path=customXml/itemProps1.xml><?xml version="1.0" encoding="utf-8"?>
+<ds:datastoreItem xmlns:ds="http://schemas.openxmlformats.org/officeDocument/2006/customXml" ds:itemID="{C64B5808-DACA-4273-92AE-F78AD06EB5C9}">
+  <ds:schemaRefs>
+    <ds:schemaRef ds:uri="http://schemas.microsoft.com/office/2006/metadata/properties"/>
+    <ds:schemaRef ds:uri="http://schemas.microsoft.com/office/infopath/2007/PartnerControls"/>
+    <ds:schemaRef ds:uri="819a213c-e595-4af7-868c-5311d0f07b09"/>
+    <ds:schemaRef ds:uri="http://schemas.microsoft.com/sharepoint/v3"/>
+    <ds:schemaRef ds:uri="43c4306d-bcae-48a3-b5b4-6245fba36c72"/>
+  </ds:schemaRefs>
+</ds:datastoreItem>
 </file>
 
-<file path=customXml/item3.xml><?xml version="1.0" encoding="utf-8"?>
-<?mso-contentType ?>
-<FormTemplates xmlns="http://schemas.microsoft.com/sharepoint/v3/contenttype/forms">
-  <Display>DocumentLibraryForm</Display>
-  <Edit>DocumentLibraryForm</Edit>
-  <New>DocumentLibraryForm</New>
-</FormTemplates>
+<file path=customXml/itemProps2.xml><?xml version="1.0" encoding="utf-8"?>
+<ds:datastoreItem xmlns:ds="http://schemas.openxmlformats.org/officeDocument/2006/customXml" ds:itemID="{D5CBC06A-5433-41AC-89E1-93399C4B6D23}">
+  <ds:schemaRefs>
+    <ds:schemaRef ds:uri="http://schemas.microsoft.com/sharepoint/v3/contenttype/forms"/>
+  </ds:schemaRefs>
+</ds:datastoreItem>
 </file>
 
-<file path=customXml/item4.xml><?xml version="1.0" encoding="utf-8"?>
-<p:properties xmlns:p="http://schemas.microsoft.com/office/2006/metadata/properties" xmlns:xsi="http://www.w3.org/2001/XMLSchema-instance" xmlns:pc="http://schemas.microsoft.com/office/infopath/2007/PartnerControls">
-  <documentManagement>
-    <Name_x0028_Outlook_x0029_ xmlns="819a213c-e595-4af7-868c-5311d0f07b09">
-      <UserInfo>
-        <DisplayName/>
-        <AccountId xsi:nil="true"/>
-        <AccountType/>
-      </UserInfo>
-    </Name_x0028_Outlook_x0029_>
-    <_ip_UnifiedCompliancePolicyUIAction xmlns="http://schemas.microsoft.com/sharepoint/v3" xsi:nil="true"/>
-    <TaxCatchAll xmlns="43c4306d-bcae-48a3-b5b4-6245fba36c72">
-      <Value>117</Value>
-      <Value>336</Value>
-      <Value>352</Value>
-      <Value>332</Value>
-      <Value>330</Value>
-      <Value>5</Value>
-      <Value>88</Value>
-      <Value>2</Value>
-      <Value>1</Value>
-    </TaxCatchAll>
-    <Project xmlns="819a213c-e595-4af7-868c-5311d0f07b09">Shrike</Project>
-    <b3e0283348f04d719dc2db6c1ad0eab0 xmlns="819a213c-e595-4af7-868c-5311d0f07b09">
-      <Terms xmlns="http://schemas.microsoft.com/office/infopath/2007/PartnerControls"/>
-    </b3e0283348f04d719dc2db6c1ad0eab0>
-    <kf4578e6b9744d06891b013fb9171991 xmlns="819a213c-e595-4af7-868c-5311d0f07b09">
-      <Terms xmlns="http://schemas.microsoft.com/office/infopath/2007/PartnerControls">
-        <TermInfo xmlns="http://schemas.microsoft.com/office/infopath/2007/PartnerControls">
-          <TermName xmlns="http://schemas.microsoft.com/office/infopath/2007/PartnerControls">FCAI</TermName>
-          <TermId xmlns="http://schemas.microsoft.com/office/infopath/2007/PartnerControls">fd9e9f27-4afa-4bd6-9815-b72522a6dee4</TermId>
-        </TermInfo>
-      </Terms>
-    </kf4578e6b9744d06891b013fb9171991>
-    <e7bf107ab2e246c2ae3b25ccb19c4fe7 xmlns="819a213c-e595-4af7-868c-5311d0f07b09">
-      <Terms xmlns="http://schemas.microsoft.com/office/infopath/2007/PartnerControls"/>
-    </e7bf107ab2e246c2ae3b25ccb19c4fe7>
-    <Status xmlns="819a213c-e595-4af7-868c-5311d0f07b09">NA</Status>
-    <k1cd0d7a50e348e5b2cecacdbb53a3ff xmlns="819a213c-e595-4af7-868c-5311d0f07b09">
-      <Terms xmlns="http://schemas.microsoft.com/office/infopath/2007/PartnerControls">
-        <TermInfo xmlns="http://schemas.microsoft.com/office/infopath/2007/PartnerControls">
-          <TermName xmlns="http://schemas.microsoft.com/office/infopath/2007/PartnerControls">NA</TermName>
-          <TermId xmlns="http://schemas.microsoft.com/office/infopath/2007/PartnerControls">6c779868-fdfe-4433-a583-74f72965e832</TermId>
-        </TermInfo>
-      </Terms>
-    </k1cd0d7a50e348e5b2cecacdbb53a3ff>
-    <k4bd3d618c344bb496a0035fa1bfa95e xmlns="819a213c-e595-4af7-868c-5311d0f07b09">
-      <Terms xmlns="http://schemas.microsoft.com/office/infopath/2007/PartnerControls">
-        <TermInfo xmlns="http://schemas.microsoft.com/office/infopath/2007/PartnerControls">
-          <TermName xmlns="http://schemas.microsoft.com/office/infopath/2007/PartnerControls">NA</TermName>
-          <TermId xmlns="http://schemas.microsoft.com/office/infopath/2007/PartnerControls">14e9068e-14f9-49cc-a753-38a742264b27</TermId>
-        </TermInfo>
-      </Terms>
-    </k4bd3d618c344bb496a0035fa1bfa95e>
-    <m3911d227d12438196938f21bccbb829 xmlns="819a213c-e595-4af7-868c-5311d0f07b09">
-      <Terms xmlns="http://schemas.microsoft.com/office/infopath/2007/PartnerControls">
-        <TermInfo xmlns="http://schemas.microsoft.com/office/infopath/2007/PartnerControls">
-          <TermName xmlns="http://schemas.microsoft.com/office/infopath/2007/PartnerControls">Unclassified</TermName>
-          <TermId xmlns="http://schemas.microsoft.com/office/infopath/2007/PartnerControls">0e44ab2e-9e75-4d69-bacf-b9adbba64961</TermId>
-        </TermInfo>
-      </Terms>
-    </m3911d227d12438196938f21bccbb829>
-    <j85403ed819e4ad59bb8aa44734c7278 xmlns="819a213c-e595-4af7-868c-5311d0f07b09">
-      <Terms xmlns="http://schemas.microsoft.com/office/infopath/2007/PartnerControls">
-        <TermInfo xmlns="http://schemas.microsoft.com/office/infopath/2007/PartnerControls">
-          <TermName xmlns="http://schemas.microsoft.com/office/infopath/2007/PartnerControls">NA</TermName>
-          <TermId xmlns="http://schemas.microsoft.com/office/infopath/2007/PartnerControls">c413e2e5-7da6-4fb4-9318-c07a4c95104c</TermId>
-        </TermInfo>
-      </Terms>
-    </j85403ed819e4ad59bb8aa44734c7278>
-    <e41571422c3345b4bda9d3ac979b0442 xmlns="819a213c-e595-4af7-868c-5311d0f07b09">
-      <Terms xmlns="http://schemas.microsoft.com/office/infopath/2007/PartnerControls">
-        <TermInfo xmlns="http://schemas.microsoft.com/office/infopath/2007/PartnerControls">
-          <TermName xmlns="http://schemas.microsoft.com/office/infopath/2007/PartnerControls">Destroy</TermName>
-          <TermId xmlns="http://schemas.microsoft.com/office/infopath/2007/PartnerControls">81460359-14dd-47b4-9102-5fada66d1614</TermId>
-        </TermInfo>
-      </Terms>
-    </e41571422c3345b4bda9d3ac979b0442>
-    <b2c7cbb6fa064dd095a8ebf73878e15c xmlns="819a213c-e595-4af7-868c-5311d0f07b09">
-      <Terms xmlns="http://schemas.microsoft.com/office/infopath/2007/PartnerControls">
-        <TermInfo xmlns="http://schemas.microsoft.com/office/infopath/2007/PartnerControls">
-          <TermName xmlns="http://schemas.microsoft.com/office/infopath/2007/PartnerControls">D</TermName>
-          <TermId xmlns="http://schemas.microsoft.com/office/infopath/2007/PartnerControls">e66b2925-d207-445d-a7ac-7bf5587a61c3</TermId>
-        </TermInfo>
-      </Terms>
-    </b2c7cbb6fa064dd095a8ebf73878e15c>
-    <n050dff107b041e7a8136cabb03c9f16 xmlns="819a213c-e595-4af7-868c-5311d0f07b09">
-      <Terms xmlns="http://schemas.microsoft.com/office/infopath/2007/PartnerControls"/>
-    </n050dff107b041e7a8136cabb03c9f16>
-    <dbcc5996da9743a2aff52ccb96daf316 xmlns="819a213c-e595-4af7-868c-5311d0f07b09">
-      <Terms xmlns="http://schemas.microsoft.com/office/infopath/2007/PartnerControls"/>
-    </dbcc5996da9743a2aff52ccb96daf316>
-    <_ip_UnifiedCompliancePolicyProperties xmlns="http://schemas.microsoft.com/sharepoint/v3" xsi:nil="true"/>
-    <Comments xmlns="819a213c-e595-4af7-868c-5311d0f07b09" xsi:nil="true"/>
-    <_dlc_DocIdPersistId xmlns="43c4306d-bcae-48a3-b5b4-6245fba36c72" xsi:nil="true"/>
-    <_dlc_DocIdUrl xmlns="43c4306d-bcae-48a3-b5b4-6245fba36c72">
-      <Url>https://armyeitaas.sharepoint-mil.us/teams/AI2CKMDevelopmentTeam/_layouts/15/DocIdRedir.aspx?ID=PNCAVZZWCJMJ-719779062-26496</Url>
-      <Description>PNCAVZZWCJMJ-719779062-26496</Description>
-    </_dlc_DocIdUrl>
-    <Teams xmlns="819a213c-e595-4af7-868c-5311d0f07b09">NA</Teams>
-    <lcf76f155ced4ddcb4097134ff3c332f xmlns="819a213c-e595-4af7-868c-5311d0f07b09">
-      <Terms xmlns="http://schemas.microsoft.com/office/infopath/2007/PartnerControls"/>
-    </lcf76f155ced4ddcb4097134ff3c332f>
-    <kf187aa08ef840c0be306c2b7cf181cc xmlns="819a213c-e595-4af7-868c-5311d0f07b09">
-      <Terms xmlns="http://schemas.microsoft.com/office/infopath/2007/PartnerControls"/>
-    </kf187aa08ef840c0be306c2b7cf181cc>
-    <k8ed72fc0ac74230bc2bce9a30aa3ff1 xmlns="819a213c-e595-4af7-868c-5311d0f07b09">
-      <Terms xmlns="http://schemas.microsoft.com/office/infopath/2007/PartnerControls"/>
-    </k8ed72fc0ac74230bc2bce9a30aa3ff1>
-    <j3cec2dc15da4ea9ae4c2914aab734b8 xmlns="819a213c-e595-4af7-868c-5311d0f07b09">
-      <Terms xmlns="http://schemas.microsoft.com/office/infopath/2007/PartnerControls">
-        <TermInfo xmlns="http://schemas.microsoft.com/office/infopath/2007/PartnerControls">
-          <TermName xmlns="http://schemas.microsoft.com/office/infopath/2007/PartnerControls">Unofficial</TermName>
-          <TermId xmlns="http://schemas.microsoft.com/office/infopath/2007/PartnerControls">fb72a3e1-cd07-4e90-8aa1-1e35bcf7448f</TermId>
-        </TermInfo>
-      </Terms>
-    </j3cec2dc15da4ea9ae4c2914aab734b8>
-    <_dlc_DocId xmlns="43c4306d-bcae-48a3-b5b4-6245fba36c72">PNCAVZZWCJMJ-719779062-26496</_dlc_DocId>
-  </documentManagement>
-</p:properties>
+<file path=customXml/itemProps3.xml><?xml version="1.0" encoding="utf-8"?>
+<ds:datastoreItem xmlns:ds="http://schemas.openxmlformats.org/officeDocument/2006/customXml" ds:itemID="{1C5A9CCD-8D95-4E29-9BBC-62ED344D200A}">
+  <ds:schemaRefs>
+    <ds:schemaRef ds:uri="http://schemas.microsoft.com/sharepoint/events"/>
+  </ds:schemaRefs>
+</ds:datastoreItem>
 </file>
 
-<file path=customXml/itemProps1.xml><?xml version="1.0" encoding="utf-8"?>
+<file path=customXml/itemProps4.xml><?xml version="1.0" encoding="utf-8"?>
 <ds:datastoreItem xmlns:ds="http://schemas.openxmlformats.org/officeDocument/2006/customXml" ds:itemID="{8F325A96-F9CD-4C1F-BC68-5ED8156DC1C7}">
   <ds:schemaRefs>
     <ds:schemaRef ds:uri="http://schemas.microsoft.com/office/2006/metadata/contentType"/>
@@ -24380,34 +24412,6 @@
 </ds:datastoreItem>
 </file>
 
-<file path=customXml/itemProps2.xml><?xml version="1.0" encoding="utf-8"?>
-<ds:datastoreItem xmlns:ds="http://schemas.openxmlformats.org/officeDocument/2006/customXml" ds:itemID="{1C5A9CCD-8D95-4E29-9BBC-62ED344D200A}">
-  <ds:schemaRefs>
-    <ds:schemaRef ds:uri="http://schemas.microsoft.com/sharepoint/events"/>
-  </ds:schemaRefs>
-</ds:datastoreItem>
-</file>
-
-<file path=customXml/itemProps3.xml><?xml version="1.0" encoding="utf-8"?>
-<ds:datastoreItem xmlns:ds="http://schemas.openxmlformats.org/officeDocument/2006/customXml" ds:itemID="{D5CBC06A-5433-41AC-89E1-93399C4B6D23}">
-  <ds:schemaRefs>
-    <ds:schemaRef ds:uri="http://schemas.microsoft.com/sharepoint/v3/contenttype/forms"/>
-  </ds:schemaRefs>
-</ds:datastoreItem>
-</file>
-
-<file path=customXml/itemProps4.xml><?xml version="1.0" encoding="utf-8"?>
-<ds:datastoreItem xmlns:ds="http://schemas.openxmlformats.org/officeDocument/2006/customXml" ds:itemID="{C64B5808-DACA-4273-92AE-F78AD06EB5C9}">
-  <ds:schemaRefs>
-    <ds:schemaRef ds:uri="http://schemas.microsoft.com/office/2006/metadata/properties"/>
-    <ds:schemaRef ds:uri="http://schemas.microsoft.com/office/infopath/2007/PartnerControls"/>
-    <ds:schemaRef ds:uri="819a213c-e595-4af7-868c-5311d0f07b09"/>
-    <ds:schemaRef ds:uri="http://schemas.microsoft.com/sharepoint/v3"/>
-    <ds:schemaRef ds:uri="43c4306d-bcae-48a3-b5b4-6245fba36c72"/>
-  </ds:schemaRefs>
-</ds:datastoreItem>
-</file>
-
 <file path=docMetadata/LabelInfo.xml><?xml version="1.0" encoding="utf-8"?>
 <clbl:labelList xmlns:clbl="http://schemas.microsoft.com/office/2020/mipLabelMetadata">
   <clbl:label id="{554eecc5-e26c-4620-b240-5a8bb326c33d}" enabled="1" method="Privileged" siteId="{fae6d70f-954b-4811-92b6-0530d6f84c43}" contentBits="0" removed="0"/>

</xml_diff>